<commit_message>
Add Module 4 project4 files and update Module 1 slides
Remove superseded module1_introduction.pptx, update the July 2026
slide deck, and add project4 practice files (script + Canvas page).

Co-Authored-By: Claude Sonnet 5 <noreply@anthropic.com>
</commit_message>
<xml_diff>
--- a/module1/module1_introduction_July2026.pptx
+++ b/module1/module1_introduction_July2026.pptx
@@ -157,14 +157,6 @@
     </p:ext>
   </p:extLst>
 </p:presentation>
-</file>
-
-<file path=ppt/revisionInfo.xml><?xml version="1.0" encoding="utf-8"?>
-<p1510:revInfo xmlns:a="http://schemas.openxmlformats.org/drawingml/2006/main" xmlns:r="http://schemas.openxmlformats.org/officeDocument/2006/relationships" xmlns:p1510="http://schemas.microsoft.com/office/powerpoint/2015/10/main">
-  <p1510:revLst>
-    <p1510:client id="{C1E18C3F-76F7-FC40-8228-D7497A810AB0}" v="249" dt="2021-08-24T14:54:44.046"/>
-  </p1510:revLst>
-</p1510:revInfo>
 </file>
 
 <file path=ppt/notesMasters/notesMaster1.xml><?xml version="1.0" encoding="utf-8"?>

</xml_diff>

<commit_message>
revision: module 1 part 5
</commit_message>
<xml_diff>
--- a/module1/module1_introduction_July2026.pptx
+++ b/module1/module1_introduction_July2026.pptx
@@ -241,7 +241,7 @@
           <a:p>
             <a:fld id="{3870BCA1-F06D-D646-A054-BB10F53155AC}" type="datetimeFigureOut">
               <a:rPr lang="en-US" smtClean="0"/>
-              <a:t>7/3/26</a:t>
+              <a:t>7/4/26</a:t>
             </a:fld>
             <a:endParaRPr lang="en-US"/>
           </a:p>
@@ -3579,7 +3579,7 @@
           <a:p>
             <a:fld id="{1D8BD707-D9CF-40AE-B4C6-C98DA3205C09}" type="datetimeFigureOut">
               <a:rPr lang="en-US"/>
-              <a:t>7/3/26</a:t>
+              <a:t>7/4/26</a:t>
             </a:fld>
             <a:endParaRPr lang="en-US"/>
           </a:p>
@@ -3712,7 +3712,7 @@
           <a:p>
             <a:fld id="{1D8BD707-D9CF-40AE-B4C6-C98DA3205C09}" type="datetimeFigureOut">
               <a:rPr lang="en-US"/>
-              <a:t>7/3/26</a:t>
+              <a:t>7/4/26</a:t>
             </a:fld>
             <a:endParaRPr lang="en-US"/>
           </a:p>
@@ -3924,7 +3924,7 @@
           <a:p>
             <a:fld id="{1D8BD707-D9CF-40AE-B4C6-C98DA3205C09}" type="datetimeFigureOut">
               <a:rPr lang="en-US"/>
-              <a:t>7/3/26</a:t>
+              <a:t>7/4/26</a:t>
             </a:fld>
             <a:endParaRPr lang="en-US"/>
           </a:p>
@@ -4057,7 +4057,7 @@
           <a:p>
             <a:fld id="{1D8BD707-D9CF-40AE-B4C6-C98DA3205C09}" type="datetimeFigureOut">
               <a:rPr lang="en-US"/>
-              <a:t>7/3/26</a:t>
+              <a:t>7/4/26</a:t>
             </a:fld>
             <a:endParaRPr lang="en-US"/>
           </a:p>
@@ -4606,7 +4606,7 @@
           <a:p>
             <a:fld id="{1D8BD707-D9CF-40AE-B4C6-C98DA3205C09}" type="datetimeFigureOut">
               <a:rPr lang="en-US"/>
-              <a:t>7/3/26</a:t>
+              <a:t>7/4/26</a:t>
             </a:fld>
             <a:endParaRPr lang="en-US"/>
           </a:p>
@@ -22005,10 +22005,7 @@
             </a:r>
           </a:p>
           <a:p>
-            <a:pPr marL="355600" indent="-342900" algn="just">
-              <a:lnSpc>
-                <a:spcPct val="100000"/>
-              </a:lnSpc>
+            <a:pPr marL="812800" lvl="1" indent="-342900" algn="just">
               <a:spcBef>
                 <a:spcPts val="100"/>
               </a:spcBef>
@@ -22027,10 +22024,7 @@
             </a:r>
           </a:p>
           <a:p>
-            <a:pPr marL="355600" indent="-342900" algn="just">
-              <a:lnSpc>
-                <a:spcPct val="100000"/>
-              </a:lnSpc>
+            <a:pPr marL="812800" lvl="1" indent="-342900" algn="just">
               <a:spcBef>
                 <a:spcPts val="100"/>
               </a:spcBef>
@@ -22050,10 +22044,7 @@
             </a:r>
           </a:p>
           <a:p>
-            <a:pPr marL="355600" indent="-342900" algn="just">
-              <a:lnSpc>
-                <a:spcPct val="100000"/>
-              </a:lnSpc>
+            <a:pPr marL="812800" lvl="1" indent="-342900" algn="just">
               <a:spcBef>
                 <a:spcPts val="100"/>
               </a:spcBef>
@@ -22073,10 +22064,7 @@
             </a:r>
           </a:p>
           <a:p>
-            <a:pPr marL="355600" indent="-342900" algn="just">
-              <a:lnSpc>
-                <a:spcPct val="100000"/>
-              </a:lnSpc>
+            <a:pPr marL="812800" lvl="1" indent="-342900" algn="just">
               <a:spcBef>
                 <a:spcPts val="100"/>
               </a:spcBef>
@@ -22167,7 +22155,7 @@
         </p:nvSpPr>
         <p:spPr>
           <a:xfrm>
-            <a:off x="609600" y="762000"/>
+            <a:off x="609600" y="3701841"/>
             <a:ext cx="5181600" cy="505267"/>
           </a:xfrm>
           <a:prstGeom prst="rect">
@@ -22233,7 +22221,7 @@
         </p:nvSpPr>
         <p:spPr>
           <a:xfrm>
-            <a:off x="1447800" y="2380673"/>
+            <a:off x="1276667" y="4216633"/>
             <a:ext cx="6590665" cy="443711"/>
           </a:xfrm>
           <a:prstGeom prst="rect">
@@ -22289,7 +22277,7 @@
         </p:nvSpPr>
         <p:spPr>
           <a:xfrm>
-            <a:off x="1232851" y="4792718"/>
+            <a:off x="1133475" y="5715000"/>
             <a:ext cx="7262814" cy="769441"/>
           </a:xfrm>
           <a:prstGeom prst="rect">
@@ -22331,7 +22319,7 @@
         </p:nvSpPr>
         <p:spPr>
           <a:xfrm>
-            <a:off x="619125" y="3871116"/>
+            <a:off x="609600" y="5209733"/>
             <a:ext cx="5181600" cy="505267"/>
           </a:xfrm>
           <a:prstGeom prst="rect">
@@ -22380,6 +22368,187 @@
               <a:ea typeface="Verdana" panose="020B0604030504040204" pitchFamily="34" charset="0"/>
               <a:cs typeface="Verdana" panose="020B0604030504040204" pitchFamily="34" charset="0"/>
             </a:endParaRPr>
+          </a:p>
+        </p:txBody>
+      </p:sp>
+      <p:sp>
+        <p:nvSpPr>
+          <p:cNvPr id="8" name="object 3">
+            <a:extLst>
+              <a:ext uri="{FF2B5EF4-FFF2-40B4-BE49-F238E27FC236}">
+                <a16:creationId xmlns:a16="http://schemas.microsoft.com/office/drawing/2014/main" id="{BDBAD913-1806-9626-B1C3-344364C507FA}"/>
+              </a:ext>
+            </a:extLst>
+          </p:cNvPr>
+          <p:cNvSpPr txBox="1">
+            <a:spLocks/>
+          </p:cNvSpPr>
+          <p:nvPr/>
+        </p:nvSpPr>
+        <p:spPr>
+          <a:xfrm>
+            <a:off x="609600" y="844372"/>
+            <a:ext cx="5181600" cy="505267"/>
+          </a:xfrm>
+          <a:prstGeom prst="rect">
+            <a:avLst/>
+          </a:prstGeom>
+        </p:spPr>
+        <p:txBody>
+          <a:bodyPr vert="horz" wrap="square" lIns="0" tIns="12700" rIns="0" bIns="0" rtlCol="0">
+            <a:spAutoFit/>
+          </a:bodyPr>
+          <a:lstStyle>
+            <a:lvl1pPr>
+              <a:defRPr>
+                <a:latin typeface="+mj-lt"/>
+                <a:ea typeface="+mj-ea"/>
+                <a:cs typeface="+mj-cs"/>
+              </a:defRPr>
+            </a:lvl1pPr>
+          </a:lstStyle>
+          <a:p>
+            <a:pPr marL="12700">
+              <a:spcBef>
+                <a:spcPts val="100"/>
+              </a:spcBef>
+            </a:pPr>
+            <a:r>
+              <a:rPr lang="en-US" sz="3200" kern="0" spc="25" dirty="0">
+                <a:solidFill>
+                  <a:schemeClr val="accent6">
+                    <a:lumMod val="75000"/>
+                  </a:schemeClr>
+                </a:solidFill>
+                <a:latin typeface="Verdana" panose="020B0604030504040204" pitchFamily="34" charset="0"/>
+                <a:ea typeface="Verdana" panose="020B0604030504040204" pitchFamily="34" charset="0"/>
+                <a:cs typeface="Verdana" panose="020B0604030504040204" pitchFamily="34" charset="0"/>
+              </a:rPr>
+              <a:t>Course Content</a:t>
+            </a:r>
+            <a:endParaRPr lang="en-US" sz="3200" kern="0" spc="35" dirty="0">
+              <a:solidFill>
+                <a:schemeClr val="accent6">
+                  <a:lumMod val="75000"/>
+                </a:schemeClr>
+              </a:solidFill>
+              <a:latin typeface="Verdana" panose="020B0604030504040204" pitchFamily="34" charset="0"/>
+              <a:ea typeface="Verdana" panose="020B0604030504040204" pitchFamily="34" charset="0"/>
+              <a:cs typeface="Verdana" panose="020B0604030504040204" pitchFamily="34" charset="0"/>
+            </a:endParaRPr>
+          </a:p>
+        </p:txBody>
+      </p:sp>
+      <p:sp>
+        <p:nvSpPr>
+          <p:cNvPr id="10" name="object 2">
+            <a:extLst>
+              <a:ext uri="{FF2B5EF4-FFF2-40B4-BE49-F238E27FC236}">
+                <a16:creationId xmlns:a16="http://schemas.microsoft.com/office/drawing/2014/main" id="{92BB4A77-7615-EA52-2118-89C6C2B04694}"/>
+              </a:ext>
+            </a:extLst>
+          </p:cNvPr>
+          <p:cNvSpPr txBox="1"/>
+          <p:nvPr/>
+        </p:nvSpPr>
+        <p:spPr>
+          <a:xfrm>
+            <a:off x="1123950" y="1439683"/>
+            <a:ext cx="6590665" cy="1756891"/>
+          </a:xfrm>
+          <a:prstGeom prst="rect">
+            <a:avLst/>
+          </a:prstGeom>
+        </p:spPr>
+        <p:txBody>
+          <a:bodyPr vert="horz" wrap="square" lIns="0" tIns="12700" rIns="0" bIns="0" rtlCol="0">
+            <a:spAutoFit/>
+          </a:bodyPr>
+          <a:lstStyle/>
+          <a:p>
+            <a:pPr marL="12700" algn="just">
+              <a:lnSpc>
+                <a:spcPct val="100000"/>
+              </a:lnSpc>
+              <a:spcBef>
+                <a:spcPts val="100"/>
+              </a:spcBef>
+            </a:pPr>
+            <a:r>
+              <a:rPr lang="en-US" sz="2200" spc="-5" dirty="0">
+                <a:latin typeface="Arial"/>
+                <a:cs typeface="Arial"/>
+              </a:rPr>
+              <a:t>Module 1. Introduction</a:t>
+            </a:r>
+          </a:p>
+          <a:p>
+            <a:pPr marL="12700" algn="just">
+              <a:lnSpc>
+                <a:spcPct val="100000"/>
+              </a:lnSpc>
+              <a:spcBef>
+                <a:spcPts val="100"/>
+              </a:spcBef>
+            </a:pPr>
+            <a:r>
+              <a:rPr lang="en-US" sz="2200" spc="-5" dirty="0">
+                <a:latin typeface="Arial"/>
+                <a:cs typeface="Arial"/>
+              </a:rPr>
+              <a:t>Module 2. Gale-Shapely Algorithm</a:t>
+            </a:r>
+          </a:p>
+          <a:p>
+            <a:pPr marL="12700" algn="just">
+              <a:lnSpc>
+                <a:spcPct val="100000"/>
+              </a:lnSpc>
+              <a:spcBef>
+                <a:spcPts val="100"/>
+              </a:spcBef>
+            </a:pPr>
+            <a:r>
+              <a:rPr lang="en-US" sz="2200" spc="-5" dirty="0">
+                <a:latin typeface="Arial"/>
+                <a:cs typeface="Arial"/>
+              </a:rPr>
+              <a:t>Module 3. Agent-Based Simulation</a:t>
+            </a:r>
+          </a:p>
+          <a:p>
+            <a:pPr marL="12700" algn="just">
+              <a:lnSpc>
+                <a:spcPct val="100000"/>
+              </a:lnSpc>
+              <a:spcBef>
+                <a:spcPts val="100"/>
+              </a:spcBef>
+            </a:pPr>
+            <a:r>
+              <a:rPr lang="en-US" sz="2200" spc="-5" dirty="0">
+                <a:latin typeface="Arial"/>
+                <a:cs typeface="Arial"/>
+              </a:rPr>
+              <a:t>Module 4. Dynamic System Simulation</a:t>
+            </a:r>
+          </a:p>
+          <a:p>
+            <a:pPr marL="12700" algn="just">
+              <a:lnSpc>
+                <a:spcPct val="100000"/>
+              </a:lnSpc>
+              <a:spcBef>
+                <a:spcPts val="100"/>
+              </a:spcBef>
+            </a:pPr>
+            <a:r>
+              <a:rPr lang="en-US" sz="2200" spc="-5" dirty="0">
+                <a:latin typeface="Arial"/>
+                <a:cs typeface="Arial"/>
+              </a:rPr>
+              <a:t>Module 5. Data Analysis and Machine Learning</a:t>
+            </a:r>
           </a:p>
         </p:txBody>
       </p:sp>

</xml_diff>